<commit_message>
fix(lab): pin current APIs and rotating free models
Gradio 6 and MCP 2.0 broke Labs 3 and 6; OpenRouter retired
the default model id. Point homework at handson-lab, not Hermes.

Co-authored-by: Cursor <cursoragent@cursor.com>
</commit_message>
<xml_diff>
--- a/presentation/ai-foundations-for-engineers.pptx
+++ b/presentation/ai-foundations-for-engineers.pptx
@@ -579,7 +579,7 @@
           <a:p>
             <a:r>
               <a:rPr lang="en-US" dirty="0"/>
-              <a:t>Welcome. Six modules, roughly 60-75 minutes each. This is a concepts course: you leave able to reason about the system and predict its failure modes. The optional hands-on lab lives in the hermes-agent-workshop folder of this repo.</a:t>
+              <a:t>Welcome. Six modules, roughly 60-75 minutes each. This is a concepts course: you leave able to reason about the system and predict its failure modes. The hands-on companion is Workshop 2 in handson-lab/ — seven notebooks. hermes-agent-workshop/ is a third, separate track: the deployed email agent.</a:t>
             </a:r>
             <a:endParaRPr lang="en-US" dirty="0"/>
           </a:p>
@@ -38902,7 +38902,7 @@
                 <a:ea typeface="Cambria" pitchFamily="34" charset="-122"/>
                 <a:cs typeface="Cambria" pitchFamily="34" charset="-120"/>
               </a:rPr>
-              <a:t>Optional lab: the hermes-agent-workshop/ folder in this repo builds a working tool-using email agent end to end in about an hour</a:t>
+              <a:t>Optional lab: handson-lab/ in this repo — seven notebooks that build these ideas by hand, from first calls to an MCP server</a:t>
             </a:r>
             <a:endParaRPr lang="en-US" sz="1500" dirty="0"/>
           </a:p>
@@ -51708,7 +51708,7 @@
         <p:spPr>
           <a:xfrm>
             <a:off x="7142836" y="3603498"/>
-            <a:ext cx="4271620" cy="875538"/>
+            <a:ext cx="4271620" cy="1130808"/>
           </a:xfrm>
           <a:prstGeom prst="rect">
             <a:avLst/>
@@ -51732,7 +51732,7 @@
                 <a:ea typeface="Calibri" pitchFamily="34" charset="-122"/>
                 <a:cs typeface="Calibri" pitchFamily="34" charset="-120"/>
               </a:rPr>
-              <a:t>Optional hands-on lab in this repo: hermes-agent-workshop/ builds a tool-using email agent from zero in about an hour</a:t>
+              <a:t>Hands-on lab in this repo: handson-lab/ (Workshop 2) — seven notebooks on a free stack; hermes-agent-workshop/ is the deployed version, an email agent in Docker</a:t>
             </a:r>
             <a:endParaRPr lang="en-US" sz="1500" dirty="0"/>
           </a:p>
@@ -53823,7 +53823,7 @@
                 <a:ea typeface="Calibri" pitchFamily="34" charset="-122"/>
                 <a:cs typeface="Calibri" pitchFamily="34" charset="-120"/>
               </a:rPr>
-              <a:t>Optional hands-on lab: hermes-agent-workshop/  ·  Slides and notes: presentation/</a:t>
+              <a:t>Hands-on lab: handson-lab/  ·  Deployed agent: hermes-agent-workshop/  ·  Slides and notes: presentation/</a:t>
             </a:r>
             <a:endParaRPr lang="en-US" sz="1300" dirty="0"/>
           </a:p>

</xml_diff>